<commit_message>
Lab 3 Activity 2: Kalman filter in 2D with odometry in predict; drop check_my_lab
Activity 2 now follows module 2 section 5 and the Lecture 2 slides: the
state is [x, y], odometry's displacement is the control input u, and GPS
(H = I) or a wall sensor (H = [1, 0]) updates it. Part A prints the
lecture's example matrix by matrix; Part B runs the filter on R2D2 in
PyBullet. Labs 1 and 3 no longer refer to a check_my_lab.py they never
shipped. The Lecture 2 slides no longer say Activity 2 uses odometry as a
velocity measurement.

Co-Authored-By: Claude Opus 5.5 <noreply@anthropic.com>
</commit_message>
<xml_diff>
--- a/lectures/Robot_Localization_and_State_Estimation.pptx
+++ b/lectures/Robot_Localization_and_State_Estimation.pptx
@@ -130,14 +130,14 @@
   <p:extLst>
     <p:ext uri="{521415D9-36F7-43E2-AB2F-B90AF26B5E84}">
       <p14:sectionLst xmlns:p14="http://schemas.microsoft.com/office/powerpoint/2010/main">
-        <p14:section name="Introduction" id="{b8ff7212-340e-76c1-2a28-24cf748d50dc}">
+        <p14:section name="Introduction" id="{e20c021a-ec43-bf25-f112-e28bbf1faf70}">
           <p14:sldIdLst>
             <p14:sldId id="256"/>
             <p14:sldId id="257"/>
             <p14:sldId id="258"/>
           </p14:sldIdLst>
         </p14:section>
-        <p14:section name="Belief and the Kalman Filter" id="{802cae1d-7cc9-0e25-3f13-ab656f4191b8}">
+        <p14:section name="Belief and the Kalman Filter" id="{5ffc63ec-a1ba-724a-fe71-cafb6d3fda82}">
           <p14:sldIdLst>
             <p14:sldId id="259"/>
             <p14:sldId id="260"/>
@@ -151,7 +151,7 @@
             <p14:sldId id="268"/>
           </p14:sldIdLst>
         </p14:section>
-        <p14:section name="Kalman with Matrices" id="{9d83736c-af3e-8514-05b0-6050ba37de97}">
+        <p14:section name="Kalman with Matrices" id="{a74354af-4fa6-54ba-e6e2-216e9983f181}">
           <p14:sldIdLst>
             <p14:sldId id="269"/>
             <p14:sldId id="270"/>
@@ -161,7 +161,7 @@
             <p14:sldId id="274"/>
           </p14:sldIdLst>
         </p14:section>
-        <p14:section name="From Theory to Your Robot" id="{1ebd61e9-bf11-d593-0d86-f486da3f085c}">
+        <p14:section name="From Theory to Your Robot" id="{84dbf75c-ba3c-238d-3276-b9002a0514af}">
           <p14:sldIdLst>
             <p14:sldId id="275"/>
             <p14:sldId id="276"/>
@@ -5616,7 +5616,7 @@
           <a:p>
             <a:r>
               <a:rPr lang="en-US" dirty="0"/>
-              <a:t>Nothing new in the equations: in 2D every number becomes a vector or a matrix. The state is a column vector, the uncertainty is a 2 by 2 covariance matrix, and dividing by P plus R becomes multiplying by an inverse. The picture changes from a bell curve to an ellipse. The diagonal entries are the variances in x and y. The off-diagonal entry says whether the errors move together: when it is zero the ellipse is aligned with the axes; when it is positive the ellipse tilts. Activity 2 uses position and velocity, so four by four matrices, but the rules are the same.</a:t>
+              <a:t>Nothing new in the equations: in 2D every number becomes a vector or a matrix. The state is a column vector, the uncertainty is a 2 by 2 covariance matrix, and dividing by P plus R becomes multiplying by an inverse. The picture changes from a bell curve to an ellipse. The diagonal entries are the variances in x and y. The off-diagonal entry says whether the errors move together: when it is zero the ellipse is aligned with the axes; when it is positive the ellipse tilts. Activity 2 starts with exactly this example in NumPy, then runs the same filter on R2D2 in PyBullet.</a:t>
             </a:r>
             <a:endParaRPr lang="en-US" dirty="0"/>
           </a:p>
@@ -6848,7 +6848,7 @@
           <a:p>
             <a:r>
               <a:rPr lang="en-US" dirty="0"/>
-              <a:t>Start with motion alone. The predict step uses the motion model, and the motion comes from odometry: the wheel encoders report how far the robot moved since the last step, and that is the control input u. The mean moves by u, and the variance grows by Q, odometry's error per step. Do it three times and P keeps growing: on its own, odometry drifts. In the simulation used in the module, the robot drives 60 metres down a straight aisle, and odometry, which over-reads by ten centimetres per second, ends 6 metres off. Mention once that some books and Activity 2 put odometry into the update step as a velocity measurement instead; the answer is almost the same.</a:t>
+              <a:t>Start with motion alone. The predict step uses the motion model, and the motion comes from odometry: the wheel encoders report how far the robot moved since the last step, and that is the control input u. The mean moves by u, and the variance grows by Q, odometry's error per step. Do it three times and P keeps growing: on its own, odometry drifts. In the simulation used in the module, the robot drives 60 metres down a straight aisle, and odometry, which over-reads by ten centimetres per second, ends 6 metres off. Mention once that some books put odometry into the update step as a velocity measurement instead; the answer is almost the same.</a:t>
             </a:r>
             <a:endParaRPr lang="en-US" dirty="0"/>
           </a:p>
@@ -13306,7 +13306,7 @@
                 <a:ea typeface="Calibri" pitchFamily="34" charset="-122"/>
                 <a:cs typeface="Calibri" pitchFamily="34" charset="-120"/>
               </a:rPr>
-              <a:t>Lab 3 Activity 2 tracks x = [x, y, vx, vy]ᵀ: the same equations with 4×4 matrices.</a:t>
+              <a:t>Lab 3 Activity 2 runs this example in NumPy, then the same filter on R2D2 in PyBullet.</a:t>
             </a:r>
             <a:endParaRPr lang="en-US" sz="1100" dirty="0"/>
           </a:p>
@@ -31493,7 +31493,7 @@
                 <a:ea typeface="Calibri" pitchFamily="34" charset="-122"/>
                 <a:cs typeface="Calibri" pitchFamily="34" charset="-120"/>
               </a:rPr>
-              <a:t>2D Kalman filter on the R2D2 robot in PyBullet, tracking an L-shaped path.</a:t>
+              <a:t>The lecture's 2D example with matrices, then R2D2 on an L-shaped path with GPS or a wall sensor.</a:t>
             </a:r>
             <a:endParaRPr lang="en-US" sz="1100" dirty="0"/>
           </a:p>
@@ -34381,7 +34381,7 @@
                 <a:ea typeface="Calibri" pitchFamily="34" charset="-122"/>
                 <a:cs typeface="Calibri" pitchFamily="34" charset="-120"/>
               </a:rPr>
-              <a:t>Some books, and Lab 3 Activity 2, treat odometry as a velocity measurement in the update step instead. The result is almost the same.</a:t>
+              <a:t>Some books treat odometry as a velocity measurement in the update step instead. The result is almost the same.</a:t>
             </a:r>
             <a:endParaRPr lang="en-US" sz="1000" dirty="0"/>
           </a:p>

</xml_diff>